<commit_message>
fix: 修复 matplotlib ax.text() 参数名 (ha -> horizontalalignment)
</commit_message>
<xml_diff>
--- a/templates/新的报告模板.pptx
+++ b/templates/新的报告模板.pptx
@@ -3600,7 +3600,7 @@
             </a:r>
             <a:r>
               <a:rPr lang="en-US" altLang="zh-CN" dirty="0" err="1"/>
-              <a:t>CHART:monthly_trend_dual</a:t>
+              <a:t>CHART:product_share_pie</a:t>
             </a:r>
             <a:r>
               <a:rPr lang="en-US" altLang="zh-CN" dirty="0"/>
@@ -3657,7 +3657,7 @@
         <p:spPr>
           <a:xfrm>
             <a:off x="1039017" y="1849030"/>
-            <a:ext cx="3226140" cy="369332"/>
+            <a:ext cx="3067443" cy="369332"/>
           </a:xfrm>
           <a:prstGeom prst="rect">
             <a:avLst/>
@@ -3676,7 +3676,7 @@
             </a:r>
             <a:r>
               <a:rPr lang="en-US" altLang="zh-CN" dirty="0" err="1"/>
-              <a:t>INSIGHT:monthly_trend_dual</a:t>
+              <a:t>INSIGHT:product_share_pie</a:t>
             </a:r>
             <a:r>
               <a:rPr lang="en-US" altLang="zh-CN" dirty="0"/>
@@ -4267,7 +4267,15 @@
           <a:p>
             <a:r>
               <a:rPr lang="zh-CN" altLang="en-US" dirty="0"/>
-              <a:t>产品销售额占比分布</a:t>
+              <a:t>核心 </a:t>
+            </a:r>
+            <a:r>
+              <a:rPr lang="en-US" altLang="zh-CN" dirty="0"/>
+              <a:t>KPI </a:t>
+            </a:r>
+            <a:r>
+              <a:rPr lang="zh-CN" altLang="en-US" dirty="0"/>
+              <a:t>指标概览</a:t>
             </a:r>
             <a:endParaRPr dirty="0"/>
           </a:p>
@@ -4320,7 +4328,7 @@
             </a:r>
             <a:r>
               <a:rPr lang="en-US" dirty="0" err="1"/>
-              <a:t>CHART:product_share</a:t>
+              <a:t>CHART:core_kpi_summary</a:t>
             </a:r>
             <a:r>
               <a:rPr lang="en-US" dirty="0"/>
@@ -4338,7 +4346,7 @@
         <p:spPr>
           <a:xfrm>
             <a:off x="8046720" y="1371600"/>
-            <a:ext cx="2661883" cy="369332"/>
+            <a:ext cx="3089628" cy="369332"/>
           </a:xfrm>
           <a:prstGeom prst="rect">
             <a:avLst/>
@@ -4357,7 +4365,7 @@
             </a:r>
             <a:r>
               <a:rPr lang="en-US" dirty="0" err="1"/>
-              <a:t>INSIGHT:product_share</a:t>
+              <a:t>INSIGHT:core_kpi_summary</a:t>
             </a:r>
             <a:r>
               <a:rPr lang="en-US" dirty="0"/>
@@ -4615,7 +4623,7 @@
             </a:r>
             <a:r>
               <a:rPr lang="en-US" dirty="0" err="1"/>
-              <a:t>CHART:city_ranking</a:t>
+              <a:t>CHART:city_ranking_horizontal</a:t>
             </a:r>
             <a:r>
               <a:rPr lang="en-US" dirty="0"/>
@@ -4634,7 +4642,7 @@
         <p:spPr>
           <a:xfrm>
             <a:off x="8046720" y="1371600"/>
-            <a:ext cx="2151871" cy="369332"/>
+            <a:ext cx="3493842" cy="369332"/>
           </a:xfrm>
           <a:prstGeom prst="rect">
             <a:avLst/>
@@ -4649,15 +4657,15 @@
           <a:p>
             <a:r>
               <a:rPr lang="en-US" dirty="0"/>
-              <a:t>[</a:t>
+              <a:t>{{</a:t>
             </a:r>
             <a:r>
               <a:rPr lang="en-US" dirty="0" err="1"/>
-              <a:t>CHART:city_ranking</a:t>
+              <a:t>INSIGHT:city_ranking_horizontal</a:t>
             </a:r>
             <a:r>
               <a:rPr lang="en-US" dirty="0"/>
-              <a:t>]</a:t>
+              <a:t>}}</a:t>
             </a:r>
             <a:endParaRPr dirty="0"/>
           </a:p>
@@ -4763,7 +4771,7 @@
             </a:r>
             <a:r>
               <a:rPr lang="en-US" dirty="0" err="1"/>
-              <a:t>CHART:salesperson_ranking</a:t>
+              <a:t>CHART:salesperson_ranking_horizontal</a:t>
             </a:r>
             <a:r>
               <a:rPr lang="en-US" dirty="0"/>
@@ -4782,7 +4790,7 @@
         <p:spPr>
           <a:xfrm>
             <a:off x="8046720" y="1371600"/>
-            <a:ext cx="3209725" cy="369332"/>
+            <a:ext cx="4267322" cy="369332"/>
           </a:xfrm>
           <a:prstGeom prst="rect">
             <a:avLst/>
@@ -4801,7 +4809,7 @@
             </a:r>
             <a:r>
               <a:rPr lang="en-US" dirty="0" err="1"/>
-              <a:t>INSIGHT:salesperson_ranking</a:t>
+              <a:t>INSIGHT:salesperson_ranking_horizontal</a:t>
             </a:r>
             <a:r>
               <a:rPr lang="en-US" dirty="0"/>
@@ -4864,7 +4872,7 @@
             </a:r>
             <a:r>
               <a:rPr lang="en-US" dirty="0" err="1"/>
-              <a:t>INSIGHT:monthly_trend_sales</a:t>
+              <a:t>INSIGHT:monthly_trend_dual</a:t>
             </a:r>
             <a:r>
               <a:rPr lang="en-US" dirty="0"/>
@@ -4949,7 +4957,7 @@
             </a:r>
             <a:r>
               <a:rPr lang="en-US" dirty="0" err="1"/>
-              <a:t>CHART:monthly_trend_sales</a:t>
+              <a:t>CHART:monthly_trend_dual</a:t>
             </a:r>
             <a:r>
               <a:rPr lang="en-US" dirty="0"/>
@@ -5006,7 +5014,7 @@
           <a:p>
             <a:r>
               <a:rPr lang="zh-CN" altLang="en-US" dirty="0"/>
-              <a:t>月度订单量趋势</a:t>
+              <a:t>自定义月度趋势</a:t>
             </a:r>
             <a:endParaRPr dirty="0"/>
           </a:p>
@@ -5059,7 +5067,7 @@
             </a:r>
             <a:r>
               <a:rPr lang="en-US" dirty="0" err="1"/>
-              <a:t>CHART:monthly_trend_orders</a:t>
+              <a:t>CHART:custom_monthly_trend_dual</a:t>
             </a:r>
             <a:r>
               <a:rPr lang="en-US" dirty="0"/>
@@ -5078,7 +5086,7 @@
         <p:spPr>
           <a:xfrm>
             <a:off x="457200" y="5212080"/>
-            <a:ext cx="3421001" cy="369332"/>
+            <a:ext cx="4029245" cy="369332"/>
           </a:xfrm>
           <a:prstGeom prst="rect">
             <a:avLst/>
@@ -5097,7 +5105,7 @@
             </a:r>
             <a:r>
               <a:rPr lang="en-US" dirty="0" err="1"/>
-              <a:t>INSIGHT:monthly_trend_orders</a:t>
+              <a:t>INSIGHT:custom_monthly_trend_dual</a:t>
             </a:r>
             <a:r>
               <a:rPr lang="en-US" dirty="0"/>

</xml_diff>

<commit_message>
docs: 完善 chart-config-recommender SKILL v2.0
更新内容:
- 明确 data_source 必须使用实际 Sheet 名称
- 详细说明每种图表类型的字段名要求
- 添加常见错误示例和正确示例对比
- 添加检查清单
- 添加完整的最佳实践示例

重点强调:
1. data_source 必须使用输入中的实际 Sheet 名称
2. 饼图使用 category_field 和 value_field
3. 多列柱状图使用 category_field 和 series（列表）
4. 字段必须存在于 Sheet 的 columns 中
</commit_message>
<xml_diff>
--- a/templates/新的报告模板.pptx
+++ b/templates/新的报告模板.pptx
@@ -17,7 +17,6 @@
     <p:sldId id="266" r:id="rId11"/>
     <p:sldId id="267" r:id="rId12"/>
     <p:sldId id="268" r:id="rId13"/>
-    <p:sldId id="269" r:id="rId14"/>
   </p:sldIdLst>
   <p:sldSz cx="12192000" cy="6858000"/>
   <p:notesSz cx="6858000" cy="9144000"/>
@@ -3537,168 +3536,6 @@
 </p:sld>
 </file>
 
-<file path=ppt/slides/slide13.xml><?xml version="1.0" encoding="utf-8"?>
-<p:sld xmlns:a="http://schemas.openxmlformats.org/drawingml/2006/main" xmlns:r="http://schemas.openxmlformats.org/officeDocument/2006/relationships" xmlns:p="http://schemas.openxmlformats.org/presentationml/2006/main">
-  <p:cSld>
-    <p:spTree>
-      <p:nvGrpSpPr>
-        <p:cNvPr id="1" name=""/>
-        <p:cNvGrpSpPr/>
-        <p:nvPr/>
-      </p:nvGrpSpPr>
-      <p:grpSpPr>
-        <a:xfrm>
-          <a:off x="0" y="0"/>
-          <a:ext cx="0" cy="0"/>
-          <a:chOff x="0" y="0"/>
-          <a:chExt cx="0" cy="0"/>
-        </a:xfrm>
-      </p:grpSpPr>
-      <p:sp>
-        <p:nvSpPr>
-          <p:cNvPr id="2" name="矩形 1">
-            <a:extLst>
-              <a:ext uri="{FF2B5EF4-FFF2-40B4-BE49-F238E27FC236}">
-                <a16:creationId xmlns:a16="http://schemas.microsoft.com/office/drawing/2014/main" id="{BE425793-6A16-ECF1-4B70-F2855E9017EA}"/>
-              </a:ext>
-            </a:extLst>
-          </p:cNvPr>
-          <p:cNvSpPr/>
-          <p:nvPr/>
-        </p:nvSpPr>
-        <p:spPr>
-          <a:xfrm>
-            <a:off x="5240458" y="1513490"/>
-            <a:ext cx="6180083" cy="4181015"/>
-          </a:xfrm>
-          <a:prstGeom prst="rect">
-            <a:avLst/>
-          </a:prstGeom>
-        </p:spPr>
-        <p:style>
-          <a:lnRef idx="1">
-            <a:schemeClr val="accent1"/>
-          </a:lnRef>
-          <a:fillRef idx="3">
-            <a:schemeClr val="accent1"/>
-          </a:fillRef>
-          <a:effectRef idx="2">
-            <a:schemeClr val="accent1"/>
-          </a:effectRef>
-          <a:fontRef idx="minor">
-            <a:schemeClr val="lt1"/>
-          </a:fontRef>
-        </p:style>
-        <p:txBody>
-          <a:bodyPr rtlCol="0" anchor="ctr"/>
-          <a:lstStyle/>
-          <a:p>
-            <a:pPr algn="ctr"/>
-            <a:r>
-              <a:rPr lang="en-US" altLang="zh-CN" dirty="0"/>
-              <a:t>[</a:t>
-            </a:r>
-            <a:r>
-              <a:rPr lang="en-US" altLang="zh-CN" dirty="0" err="1"/>
-              <a:t>CHART:product_share_pie</a:t>
-            </a:r>
-            <a:r>
-              <a:rPr lang="en-US" altLang="zh-CN" dirty="0"/>
-              <a:t>]</a:t>
-            </a:r>
-            <a:endParaRPr lang="zh-CN" altLang="en-US" dirty="0"/>
-          </a:p>
-        </p:txBody>
-      </p:sp>
-      <p:sp>
-        <p:nvSpPr>
-          <p:cNvPr id="3" name="文本框 2">
-            <a:extLst>
-              <a:ext uri="{FF2B5EF4-FFF2-40B4-BE49-F238E27FC236}">
-                <a16:creationId xmlns:a16="http://schemas.microsoft.com/office/drawing/2014/main" id="{29A9A806-473D-37B7-BE4F-455A7EF285BA}"/>
-              </a:ext>
-            </a:extLst>
-          </p:cNvPr>
-          <p:cNvSpPr txBox="1"/>
-          <p:nvPr/>
-        </p:nvSpPr>
-        <p:spPr>
-          <a:xfrm>
-            <a:off x="1705855" y="3672968"/>
-            <a:ext cx="184731" cy="369332"/>
-          </a:xfrm>
-          <a:prstGeom prst="rect">
-            <a:avLst/>
-          </a:prstGeom>
-          <a:noFill/>
-        </p:spPr>
-        <p:txBody>
-          <a:bodyPr wrap="none" rtlCol="0">
-            <a:spAutoFit/>
-          </a:bodyPr>
-          <a:lstStyle/>
-          <a:p>
-            <a:endParaRPr lang="zh-CN" altLang="en-US" dirty="0"/>
-          </a:p>
-        </p:txBody>
-      </p:sp>
-      <p:sp>
-        <p:nvSpPr>
-          <p:cNvPr id="8" name="TextBox 4">
-            <a:extLst>
-              <a:ext uri="{FF2B5EF4-FFF2-40B4-BE49-F238E27FC236}">
-                <a16:creationId xmlns:a16="http://schemas.microsoft.com/office/drawing/2014/main" id="{38BA3899-CA74-E6FD-4376-3E353B599B76}"/>
-              </a:ext>
-            </a:extLst>
-          </p:cNvPr>
-          <p:cNvSpPr txBox="1"/>
-          <p:nvPr/>
-        </p:nvSpPr>
-        <p:spPr>
-          <a:xfrm>
-            <a:off x="1039017" y="1849030"/>
-            <a:ext cx="3067443" cy="369332"/>
-          </a:xfrm>
-          <a:prstGeom prst="rect">
-            <a:avLst/>
-          </a:prstGeom>
-          <a:noFill/>
-        </p:spPr>
-        <p:txBody>
-          <a:bodyPr wrap="none">
-            <a:spAutoFit/>
-          </a:bodyPr>
-          <a:lstStyle/>
-          <a:p>
-            <a:r>
-              <a:rPr lang="en-US" altLang="zh-CN" dirty="0"/>
-              <a:t>{{</a:t>
-            </a:r>
-            <a:r>
-              <a:rPr lang="en-US" altLang="zh-CN" dirty="0" err="1"/>
-              <a:t>INSIGHT:product_share_pie</a:t>
-            </a:r>
-            <a:r>
-              <a:rPr lang="en-US" altLang="zh-CN" dirty="0"/>
-              <a:t>}}</a:t>
-            </a:r>
-            <a:endParaRPr dirty="0"/>
-          </a:p>
-        </p:txBody>
-      </p:sp>
-    </p:spTree>
-    <p:extLst>
-      <p:ext uri="{BB962C8B-B14F-4D97-AF65-F5344CB8AC3E}">
-        <p14:creationId xmlns:p14="http://schemas.microsoft.com/office/powerpoint/2010/main" val="68283920"/>
-      </p:ext>
-    </p:extLst>
-  </p:cSld>
-  <p:clrMapOvr>
-    <a:masterClrMapping/>
-  </p:clrMapOvr>
-</p:sld>
-</file>
-
 <file path=ppt/slides/slide2.xml><?xml version="1.0" encoding="utf-8"?>
 <p:sld xmlns:a="http://schemas.openxmlformats.org/drawingml/2006/main" xmlns:r="http://schemas.openxmlformats.org/officeDocument/2006/relationships" xmlns:p="http://schemas.openxmlformats.org/presentationml/2006/main">
   <p:cSld>
@@ -4422,7 +4259,7 @@
           <a:p>
             <a:r>
               <a:rPr lang="zh-CN" altLang="en-US" dirty="0"/>
-              <a:t>新客与老客经营效能对比</a:t>
+              <a:t>销售员业绩排名分析</a:t>
             </a:r>
             <a:endParaRPr dirty="0"/>
           </a:p>
@@ -4475,7 +4312,7 @@
             </a:r>
             <a:r>
               <a:rPr lang="en-US" dirty="0" err="1"/>
-              <a:t>CHART:customer_type_comparison</a:t>
+              <a:t>CHART:salesperson_ranking</a:t>
             </a:r>
             <a:r>
               <a:rPr lang="en-US" dirty="0"/>
@@ -4494,7 +4331,7 @@
         <p:spPr>
           <a:xfrm>
             <a:off x="5760720" y="1371600"/>
-            <a:ext cx="3926652" cy="369332"/>
+            <a:ext cx="3209725" cy="369332"/>
           </a:xfrm>
           <a:prstGeom prst="rect">
             <a:avLst/>
@@ -4513,7 +4350,7 @@
             </a:r>
             <a:r>
               <a:rPr lang="en-US" dirty="0" err="1"/>
-              <a:t>INSIGHT:customer_type_comparison</a:t>
+              <a:t>INSIGHT:salesperson_ranking</a:t>
             </a:r>
             <a:r>
               <a:rPr lang="en-US" dirty="0"/>
@@ -4570,7 +4407,7 @@
           <a:p>
             <a:r>
               <a:rPr lang="zh-CN" altLang="en-US" dirty="0"/>
-              <a:t>城市销售业绩排名</a:t>
+              <a:t>城市销售占比分布</a:t>
             </a:r>
             <a:endParaRPr dirty="0"/>
           </a:p>
@@ -4623,7 +4460,7 @@
             </a:r>
             <a:r>
               <a:rPr lang="en-US" dirty="0" err="1"/>
-              <a:t>CHART:city_ranking_horizontal</a:t>
+              <a:t>CHART:city_sales_pie</a:t>
             </a:r>
             <a:r>
               <a:rPr lang="en-US" dirty="0"/>
@@ -4642,7 +4479,7 @@
         <p:spPr>
           <a:xfrm>
             <a:off x="8046720" y="1371600"/>
-            <a:ext cx="3493842" cy="369332"/>
+            <a:ext cx="2604496" cy="369332"/>
           </a:xfrm>
           <a:prstGeom prst="rect">
             <a:avLst/>
@@ -4661,7 +4498,7 @@
             </a:r>
             <a:r>
               <a:rPr lang="en-US" dirty="0" err="1"/>
-              <a:t>INSIGHT:city_ranking_horizontal</a:t>
+              <a:t>INSIGHT:city_sales_pie</a:t>
             </a:r>
             <a:r>
               <a:rPr lang="en-US" dirty="0"/>
@@ -4718,7 +4555,7 @@
           <a:p>
             <a:r>
               <a:rPr lang="zh-CN" altLang="en-US" dirty="0"/>
-              <a:t>销售员业绩排名</a:t>
+              <a:t>新老客销售与订单对比</a:t>
             </a:r>
             <a:endParaRPr dirty="0"/>
           </a:p>
@@ -4771,7 +4608,7 @@
             </a:r>
             <a:r>
               <a:rPr lang="en-US" dirty="0" err="1"/>
-              <a:t>CHART:salesperson_ranking_horizontal</a:t>
+              <a:t>CHART:customer_segment_comparison</a:t>
             </a:r>
             <a:r>
               <a:rPr lang="en-US" dirty="0"/>
@@ -4790,7 +4627,7 @@
         <p:spPr>
           <a:xfrm>
             <a:off x="8046720" y="1371600"/>
-            <a:ext cx="4267322" cy="369332"/>
+            <a:ext cx="4318875" cy="369332"/>
           </a:xfrm>
           <a:prstGeom prst="rect">
             <a:avLst/>
@@ -4809,7 +4646,7 @@
             </a:r>
             <a:r>
               <a:rPr lang="en-US" dirty="0" err="1"/>
-              <a:t>INSIGHT:salesperson_ranking_horizontal</a:t>
+              <a:t>INSIGHT:customer_segment_comparison</a:t>
             </a:r>
             <a:r>
               <a:rPr lang="en-US" dirty="0"/>
@@ -4872,7 +4709,7 @@
             </a:r>
             <a:r>
               <a:rPr lang="en-US" dirty="0" err="1"/>
-              <a:t>INSIGHT:monthly_trend_dual</a:t>
+              <a:t>INSIGHT:monthly_sales_trend</a:t>
             </a:r>
             <a:r>
               <a:rPr lang="en-US" dirty="0"/>
@@ -4904,7 +4741,7 @@
           <a:p>
             <a:r>
               <a:rPr lang="zh-CN" altLang="en-US" dirty="0"/>
-              <a:t>月度销售额与订单趋势</a:t>
+              <a:t>月度销售趋势分析</a:t>
             </a:r>
             <a:endParaRPr dirty="0"/>
           </a:p>
@@ -4957,7 +4794,7 @@
             </a:r>
             <a:r>
               <a:rPr lang="en-US" dirty="0" err="1"/>
-              <a:t>CHART:monthly_trend_dual</a:t>
+              <a:t>CHART:monthly_sales_trend</a:t>
             </a:r>
             <a:r>
               <a:rPr lang="en-US" dirty="0"/>

</xml_diff>

<commit_message>
docs: 完善 chart-config-recommender SKILL v4.0 - 明确所有可用图表类型
核心修改:
- 列出所有 Python 代码已实现的图表类型（17 种）
- 基础图表（6 种）：bar_horizontal, bar_vertical, pie, line, heatmap, multi_column
- 高级图表（5 种）：area, errorbar, polar, waterfall, funnel
- 分布图表（6 种）：scatter, histogram, boxplot, violin, bubble
- 明确每种图表类型需要的字段名
- 添加图表类型选择建议表
- 添加常见错误示例

确保 AI 只推荐 Python 代码实际支持的图表类型！
</commit_message>
<xml_diff>
--- a/templates/新的报告模板.pptx
+++ b/templates/新的报告模板.pptx
@@ -4460,7 +4460,7 @@
             </a:r>
             <a:r>
               <a:rPr lang="en-US" dirty="0" err="1"/>
-              <a:t>CHART:city_sales_pie</a:t>
+              <a:t>CHART:city_composition</a:t>
             </a:r>
             <a:r>
               <a:rPr lang="en-US" dirty="0"/>
@@ -4479,7 +4479,7 @@
         <p:spPr>
           <a:xfrm>
             <a:off x="8046720" y="1371600"/>
-            <a:ext cx="2604496" cy="369332"/>
+            <a:ext cx="2902333" cy="369332"/>
           </a:xfrm>
           <a:prstGeom prst="rect">
             <a:avLst/>
@@ -4498,7 +4498,7 @@
             </a:r>
             <a:r>
               <a:rPr lang="en-US" dirty="0" err="1"/>
-              <a:t>INSIGHT:city_sales_pie</a:t>
+              <a:t>INSIGHT:city_composition</a:t>
             </a:r>
             <a:r>
               <a:rPr lang="en-US" dirty="0"/>
@@ -4608,7 +4608,7 @@
             </a:r>
             <a:r>
               <a:rPr lang="en-US" dirty="0" err="1"/>
-              <a:t>CHART:customer_segment_comparison</a:t>
+              <a:t>CHART:customer_attribute_comparison</a:t>
             </a:r>
             <a:r>
               <a:rPr lang="en-US" dirty="0"/>
@@ -4646,7 +4646,7 @@
             </a:r>
             <a:r>
               <a:rPr lang="en-US" dirty="0" err="1"/>
-              <a:t>INSIGHT:customer_segment_comparison</a:t>
+              <a:t>INSIGHT:customer_attribute_comparison</a:t>
             </a:r>
             <a:r>
               <a:rPr lang="en-US" dirty="0"/>
@@ -4904,7 +4904,7 @@
             </a:r>
             <a:r>
               <a:rPr lang="en-US" dirty="0" err="1"/>
-              <a:t>CHART:custom_monthly_trend_dual</a:t>
+              <a:t>CHART:anomaly_orders_table</a:t>
             </a:r>
             <a:r>
               <a:rPr lang="en-US" dirty="0"/>
@@ -4923,7 +4923,7 @@
         <p:spPr>
           <a:xfrm>
             <a:off x="457200" y="5212080"/>
-            <a:ext cx="4029245" cy="369332"/>
+            <a:ext cx="3407279" cy="369332"/>
           </a:xfrm>
           <a:prstGeom prst="rect">
             <a:avLst/>
@@ -4942,7 +4942,7 @@
             </a:r>
             <a:r>
               <a:rPr lang="en-US" dirty="0" err="1"/>
-              <a:t>INSIGHT:custom_monthly_trend_dual</a:t>
+              <a:t>INSIGHT:anomaly_orders_table</a:t>
             </a:r>
             <a:r>
               <a:rPr lang="en-US" dirty="0"/>

</xml_diff>